<commit_message>
phase3: correct empty native template lineage
</commit_message>
<xml_diff>
--- a/thesis-deck-system/artifacts/phase3/sanitized-native-template.pptx
+++ b/thesis-deck-system/artifacts/phase3/sanitized-native-template.pptx
@@ -4,10 +4,6 @@
   <p:sldMasterIdLst>
     <p:sldMasterId id="2147483648" r:id="rId1"/>
   </p:sldMasterIdLst>
-  <p:sldIdLst>
-    <p:sldId id="256" r:id="rId7"/>
-    <p:sldId id="257" r:id="rId8"/>
-  </p:sldIdLst>
   <p:sldSz cx="12191999" cy="6858000" type="screen4x3"/>
   <p:notesSz cx="6858000" cy="9144000"/>
   <p:defaultTextStyle>
@@ -3077,126 +3073,6 @@
     </p:otherStyle>
   </p:txStyles>
 </p:sldMaster>
-</file>
-
-<file path=ppt/slides/slide1.xml><?xml version="1.0" encoding="utf-8"?>
-<p:sld xmlns:a="http://schemas.openxmlformats.org/drawingml/2006/main" xmlns:p="http://schemas.openxmlformats.org/presentationml/2006/main" xmlns:r="http://schemas.openxmlformats.org/officeDocument/2006/relationships">
-  <p:cSld>
-    <p:spTree>
-      <p:nvGrpSpPr>
-        <p:cNvPr id="1" name=""/>
-        <p:cNvGrpSpPr/>
-        <p:nvPr/>
-      </p:nvGrpSpPr>
-      <p:grpSpPr/>
-      <p:sp>
-        <p:nvSpPr>
-          <p:cNvPr id="2" name="Title 1"/>
-          <p:cNvSpPr>
-            <a:spLocks noGrp="1"/>
-          </p:cNvSpPr>
-          <p:nvPr>
-            <p:ph type="ctrTitle"/>
-          </p:nvPr>
-        </p:nvSpPr>
-        <p:spPr/>
-        <p:txBody>
-          <a:bodyPr/>
-          <a:lstStyle/>
-          <a:p>
-            <a:r>
-              <a:t>Synthetic Native Template</a:t>
-            </a:r>
-          </a:p>
-        </p:txBody>
-      </p:sp>
-      <p:sp>
-        <p:nvSpPr>
-          <p:cNvPr id="3" name="Subtitle 2"/>
-          <p:cNvSpPr>
-            <a:spLocks noGrp="1"/>
-          </p:cNvSpPr>
-          <p:nvPr>
-            <p:ph type="subTitle" idx="1"/>
-          </p:nvPr>
-        </p:nvSpPr>
-        <p:spPr/>
-        <p:txBody>
-          <a:bodyPr/>
-          <a:lstStyle/>
-          <a:p>
-            <a:r>
-              <a:t>Redistributable test fixture — not laboratory data</a:t>
-            </a:r>
-          </a:p>
-        </p:txBody>
-      </p:sp>
-    </p:spTree>
-  </p:cSld>
-  <p:clrMapOvr>
-    <a:masterClrMapping/>
-  </p:clrMapOvr>
-</p:sld>
-</file>
-
-<file path=ppt/slides/slide2.xml><?xml version="1.0" encoding="utf-8"?>
-<p:sld xmlns:a="http://schemas.openxmlformats.org/drawingml/2006/main" xmlns:p="http://schemas.openxmlformats.org/presentationml/2006/main" xmlns:r="http://schemas.openxmlformats.org/officeDocument/2006/relationships">
-  <p:cSld>
-    <p:spTree>
-      <p:nvGrpSpPr>
-        <p:cNvPr id="1" name=""/>
-        <p:cNvGrpSpPr/>
-        <p:nvPr/>
-      </p:nvGrpSpPr>
-      <p:grpSpPr/>
-      <p:sp>
-        <p:nvSpPr>
-          <p:cNvPr id="2" name="Title 1"/>
-          <p:cNvSpPr>
-            <a:spLocks noGrp="1"/>
-          </p:cNvSpPr>
-          <p:nvPr>
-            <p:ph type="title"/>
-          </p:nvPr>
-        </p:nvSpPr>
-        <p:spPr/>
-        <p:txBody>
-          <a:bodyPr/>
-          <a:lstStyle/>
-          <a:p>
-            <a:r>
-              <a:t>Representative content layout</a:t>
-            </a:r>
-          </a:p>
-        </p:txBody>
-      </p:sp>
-      <p:sp>
-        <p:nvSpPr>
-          <p:cNvPr id="3" name="Content Placeholder 2"/>
-          <p:cNvSpPr>
-            <a:spLocks noGrp="1"/>
-          </p:cNvSpPr>
-          <p:nvPr>
-            <p:ph idx="1"/>
-          </p:nvPr>
-        </p:nvSpPr>
-        <p:spPr/>
-        <p:txBody>
-          <a:bodyPr/>
-          <a:lstStyle/>
-          <a:p>
-            <a:r>
-              <a:t>Native title/content placeholders</a:t>
-            </a:r>
-          </a:p>
-        </p:txBody>
-      </p:sp>
-    </p:spTree>
-  </p:cSld>
-  <p:clrMapOvr>
-    <a:masterClrMapping/>
-  </p:clrMapOvr>
-</p:sld>
 </file>
 
 <file path=ppt/theme/theme1.xml><?xml version="1.0" encoding="utf-8"?>

</xml_diff>